<commit_message>
add browser dark mode support via CSS custom properties
Convert all SCSS color variables to CSS custom properties with light
mode defaults in :root and dark mode overrides in
@media (prefers-color-scheme: dark). All other SCSS files updated to use var(--...) directly.

Also includes: GitHub Dark syntax highlighting theme, Google CSE search results dark mode styling, white background on SVG diagrams, and badge text pinned to black on orange.

Co-Authored-By: Claude Sonnet 4.6 <noreply@anthropic.com>
</commit_message>
<xml_diff>
--- a/src/CryptoProvidersSigningFlow.pptx
+++ b/src/CryptoProvidersSigningFlow.pptx
@@ -2,12 +2,12 @@
 <file path=ppt/presentation.xml><?xml version="1.0" encoding="utf-8"?>
 <p:presentation xmlns:a="http://schemas.openxmlformats.org/drawingml/2006/main" xmlns:r="http://schemas.openxmlformats.org/officeDocument/2006/relationships" xmlns:p="http://schemas.openxmlformats.org/presentationml/2006/main" saveSubsetFonts="1">
   <p:sldMasterIdLst>
-    <p:sldMasterId id="2147483672" r:id="rId1"/>
+    <p:sldMasterId id="2147483684" r:id="rId1"/>
   </p:sldMasterIdLst>
   <p:sldIdLst>
     <p:sldId id="256" r:id="rId2"/>
   </p:sldIdLst>
-  <p:sldSz cx="12192000" cy="4319588"/>
+  <p:sldSz cx="12023725" cy="4319588"/>
   <p:notesSz cx="6858000" cy="9144000"/>
   <p:defaultTextStyle>
     <a:defPPr>
@@ -141,8 +141,8 @@
         </p:nvSpPr>
         <p:spPr>
           <a:xfrm>
-            <a:off x="1524000" y="706933"/>
-            <a:ext cx="9144000" cy="1503857"/>
+            <a:off x="1502966" y="706933"/>
+            <a:ext cx="9017794" cy="1503857"/>
           </a:xfrm>
         </p:spPr>
         <p:txBody>
@@ -173,8 +173,8 @@
         </p:nvSpPr>
         <p:spPr>
           <a:xfrm>
-            <a:off x="1524000" y="2268784"/>
-            <a:ext cx="9144000" cy="1042900"/>
+            <a:off x="1502966" y="2268784"/>
+            <a:ext cx="9017794" cy="1042900"/>
           </a:xfrm>
         </p:spPr>
         <p:txBody>
@@ -243,7 +243,7 @@
           <a:p>
             <a:fld id="{98DAC7ED-0124-4475-AB10-3A7CB843D580}" type="datetimeFigureOut">
               <a:rPr lang="de-AT" smtClean="0"/>
-              <a:t>06.03.2024</a:t>
+              <a:t>16.06.2026</a:t>
             </a:fld>
             <a:endParaRPr lang="de-AT"/>
           </a:p>
@@ -294,7 +294,7 @@
     </p:spTree>
     <p:extLst>
       <p:ext uri="{BB962C8B-B14F-4D97-AF65-F5344CB8AC3E}">
-        <p14:creationId xmlns:p14="http://schemas.microsoft.com/office/powerpoint/2010/main" val="1645485002"/>
+        <p14:creationId xmlns:p14="http://schemas.microsoft.com/office/powerpoint/2010/main" val="61829864"/>
       </p:ext>
     </p:extLst>
   </p:cSld>
@@ -413,7 +413,7 @@
           <a:p>
             <a:fld id="{98DAC7ED-0124-4475-AB10-3A7CB843D580}" type="datetimeFigureOut">
               <a:rPr lang="de-AT" smtClean="0"/>
-              <a:t>06.03.2024</a:t>
+              <a:t>16.06.2026</a:t>
             </a:fld>
             <a:endParaRPr lang="de-AT"/>
           </a:p>
@@ -464,7 +464,7 @@
     </p:spTree>
     <p:extLst>
       <p:ext uri="{BB962C8B-B14F-4D97-AF65-F5344CB8AC3E}">
-        <p14:creationId xmlns:p14="http://schemas.microsoft.com/office/powerpoint/2010/main" val="3832896940"/>
+        <p14:creationId xmlns:p14="http://schemas.microsoft.com/office/powerpoint/2010/main" val="3120082836"/>
       </p:ext>
     </p:extLst>
   </p:cSld>
@@ -503,8 +503,8 @@
         </p:nvSpPr>
         <p:spPr>
           <a:xfrm>
-            <a:off x="8724900" y="229978"/>
-            <a:ext cx="2628900" cy="3660651"/>
+            <a:off x="8604478" y="229978"/>
+            <a:ext cx="2592616" cy="3660651"/>
           </a:xfrm>
         </p:spPr>
         <p:txBody>
@@ -531,8 +531,8 @@
         </p:nvSpPr>
         <p:spPr>
           <a:xfrm>
-            <a:off x="838200" y="229978"/>
-            <a:ext cx="7734300" cy="3660651"/>
+            <a:off x="826631" y="229978"/>
+            <a:ext cx="7627551" cy="3660651"/>
           </a:xfrm>
         </p:spPr>
         <p:txBody>
@@ -593,7 +593,7 @@
           <a:p>
             <a:fld id="{98DAC7ED-0124-4475-AB10-3A7CB843D580}" type="datetimeFigureOut">
               <a:rPr lang="de-AT" smtClean="0"/>
-              <a:t>06.03.2024</a:t>
+              <a:t>16.06.2026</a:t>
             </a:fld>
             <a:endParaRPr lang="de-AT"/>
           </a:p>
@@ -644,7 +644,7 @@
     </p:spTree>
     <p:extLst>
       <p:ext uri="{BB962C8B-B14F-4D97-AF65-F5344CB8AC3E}">
-        <p14:creationId xmlns:p14="http://schemas.microsoft.com/office/powerpoint/2010/main" val="438466961"/>
+        <p14:creationId xmlns:p14="http://schemas.microsoft.com/office/powerpoint/2010/main" val="161495411"/>
       </p:ext>
     </p:extLst>
   </p:cSld>
@@ -763,7 +763,7 @@
           <a:p>
             <a:fld id="{98DAC7ED-0124-4475-AB10-3A7CB843D580}" type="datetimeFigureOut">
               <a:rPr lang="de-AT" smtClean="0"/>
-              <a:t>06.03.2024</a:t>
+              <a:t>16.06.2026</a:t>
             </a:fld>
             <a:endParaRPr lang="de-AT"/>
           </a:p>
@@ -814,7 +814,7 @@
     </p:spTree>
     <p:extLst>
       <p:ext uri="{BB962C8B-B14F-4D97-AF65-F5344CB8AC3E}">
-        <p14:creationId xmlns:p14="http://schemas.microsoft.com/office/powerpoint/2010/main" val="4170834508"/>
+        <p14:creationId xmlns:p14="http://schemas.microsoft.com/office/powerpoint/2010/main" val="4138345331"/>
       </p:ext>
     </p:extLst>
   </p:cSld>
@@ -853,8 +853,8 @@
         </p:nvSpPr>
         <p:spPr>
           <a:xfrm>
-            <a:off x="831850" y="1076898"/>
-            <a:ext cx="10515600" cy="1796828"/>
+            <a:off x="820369" y="1076898"/>
+            <a:ext cx="10370463" cy="1796828"/>
           </a:xfrm>
         </p:spPr>
         <p:txBody>
@@ -885,8 +885,8 @@
         </p:nvSpPr>
         <p:spPr>
           <a:xfrm>
-            <a:off x="831850" y="2890725"/>
-            <a:ext cx="10515600" cy="944910"/>
+            <a:off x="820369" y="2890725"/>
+            <a:ext cx="10370463" cy="944910"/>
           </a:xfrm>
         </p:spPr>
         <p:txBody>
@@ -1009,7 +1009,7 @@
           <a:p>
             <a:fld id="{98DAC7ED-0124-4475-AB10-3A7CB843D580}" type="datetimeFigureOut">
               <a:rPr lang="de-AT" smtClean="0"/>
-              <a:t>06.03.2024</a:t>
+              <a:t>16.06.2026</a:t>
             </a:fld>
             <a:endParaRPr lang="de-AT"/>
           </a:p>
@@ -1060,7 +1060,7 @@
     </p:spTree>
     <p:extLst>
       <p:ext uri="{BB962C8B-B14F-4D97-AF65-F5344CB8AC3E}">
-        <p14:creationId xmlns:p14="http://schemas.microsoft.com/office/powerpoint/2010/main" val="1051987073"/>
+        <p14:creationId xmlns:p14="http://schemas.microsoft.com/office/powerpoint/2010/main" val="3693637662"/>
       </p:ext>
     </p:extLst>
   </p:cSld>
@@ -1122,8 +1122,8 @@
         </p:nvSpPr>
         <p:spPr>
           <a:xfrm>
-            <a:off x="838200" y="1149890"/>
-            <a:ext cx="5181600" cy="2740739"/>
+            <a:off x="826631" y="1149890"/>
+            <a:ext cx="5110083" cy="2740739"/>
           </a:xfrm>
         </p:spPr>
         <p:txBody>
@@ -1179,8 +1179,8 @@
         </p:nvSpPr>
         <p:spPr>
           <a:xfrm>
-            <a:off x="6172200" y="1149890"/>
-            <a:ext cx="5181600" cy="2740739"/>
+            <a:off x="6087011" y="1149890"/>
+            <a:ext cx="5110083" cy="2740739"/>
           </a:xfrm>
         </p:spPr>
         <p:txBody>
@@ -1241,7 +1241,7 @@
           <a:p>
             <a:fld id="{98DAC7ED-0124-4475-AB10-3A7CB843D580}" type="datetimeFigureOut">
               <a:rPr lang="de-AT" smtClean="0"/>
-              <a:t>06.03.2024</a:t>
+              <a:t>16.06.2026</a:t>
             </a:fld>
             <a:endParaRPr lang="de-AT"/>
           </a:p>
@@ -1292,7 +1292,7 @@
     </p:spTree>
     <p:extLst>
       <p:ext uri="{BB962C8B-B14F-4D97-AF65-F5344CB8AC3E}">
-        <p14:creationId xmlns:p14="http://schemas.microsoft.com/office/powerpoint/2010/main" val="4252607182"/>
+        <p14:creationId xmlns:p14="http://schemas.microsoft.com/office/powerpoint/2010/main" val="4200752655"/>
       </p:ext>
     </p:extLst>
   </p:cSld>
@@ -1331,8 +1331,8 @@
         </p:nvSpPr>
         <p:spPr>
           <a:xfrm>
-            <a:off x="839788" y="229978"/>
-            <a:ext cx="10515600" cy="834921"/>
+            <a:off x="828197" y="229978"/>
+            <a:ext cx="10370463" cy="834921"/>
           </a:xfrm>
         </p:spPr>
         <p:txBody>
@@ -1359,8 +1359,8 @@
         </p:nvSpPr>
         <p:spPr>
           <a:xfrm>
-            <a:off x="839789" y="1058899"/>
-            <a:ext cx="5157787" cy="518950"/>
+            <a:off x="828198" y="1058899"/>
+            <a:ext cx="5086599" cy="518950"/>
           </a:xfrm>
         </p:spPr>
         <p:txBody>
@@ -1424,8 +1424,8 @@
         </p:nvSpPr>
         <p:spPr>
           <a:xfrm>
-            <a:off x="839789" y="1577849"/>
-            <a:ext cx="5157787" cy="2320779"/>
+            <a:off x="828198" y="1577849"/>
+            <a:ext cx="5086599" cy="2320779"/>
           </a:xfrm>
         </p:spPr>
         <p:txBody>
@@ -1481,8 +1481,8 @@
         </p:nvSpPr>
         <p:spPr>
           <a:xfrm>
-            <a:off x="6172200" y="1058899"/>
-            <a:ext cx="5183188" cy="518950"/>
+            <a:off x="6087011" y="1058899"/>
+            <a:ext cx="5111649" cy="518950"/>
           </a:xfrm>
         </p:spPr>
         <p:txBody>
@@ -1546,8 +1546,8 @@
         </p:nvSpPr>
         <p:spPr>
           <a:xfrm>
-            <a:off x="6172200" y="1577849"/>
-            <a:ext cx="5183188" cy="2320779"/>
+            <a:off x="6087011" y="1577849"/>
+            <a:ext cx="5111649" cy="2320779"/>
           </a:xfrm>
         </p:spPr>
         <p:txBody>
@@ -1608,7 +1608,7 @@
           <a:p>
             <a:fld id="{98DAC7ED-0124-4475-AB10-3A7CB843D580}" type="datetimeFigureOut">
               <a:rPr lang="de-AT" smtClean="0"/>
-              <a:t>06.03.2024</a:t>
+              <a:t>16.06.2026</a:t>
             </a:fld>
             <a:endParaRPr lang="de-AT"/>
           </a:p>
@@ -1659,7 +1659,7 @@
     </p:spTree>
     <p:extLst>
       <p:ext uri="{BB962C8B-B14F-4D97-AF65-F5344CB8AC3E}">
-        <p14:creationId xmlns:p14="http://schemas.microsoft.com/office/powerpoint/2010/main" val="775762744"/>
+        <p14:creationId xmlns:p14="http://schemas.microsoft.com/office/powerpoint/2010/main" val="670041763"/>
       </p:ext>
     </p:extLst>
   </p:cSld>
@@ -1726,7 +1726,7 @@
           <a:p>
             <a:fld id="{98DAC7ED-0124-4475-AB10-3A7CB843D580}" type="datetimeFigureOut">
               <a:rPr lang="de-AT" smtClean="0"/>
-              <a:t>06.03.2024</a:t>
+              <a:t>16.06.2026</a:t>
             </a:fld>
             <a:endParaRPr lang="de-AT"/>
           </a:p>
@@ -1777,7 +1777,7 @@
     </p:spTree>
     <p:extLst>
       <p:ext uri="{BB962C8B-B14F-4D97-AF65-F5344CB8AC3E}">
-        <p14:creationId xmlns:p14="http://schemas.microsoft.com/office/powerpoint/2010/main" val="2725636920"/>
+        <p14:creationId xmlns:p14="http://schemas.microsoft.com/office/powerpoint/2010/main" val="2010534612"/>
       </p:ext>
     </p:extLst>
   </p:cSld>
@@ -1821,7 +1821,7 @@
           <a:p>
             <a:fld id="{98DAC7ED-0124-4475-AB10-3A7CB843D580}" type="datetimeFigureOut">
               <a:rPr lang="de-AT" smtClean="0"/>
-              <a:t>06.03.2024</a:t>
+              <a:t>16.06.2026</a:t>
             </a:fld>
             <a:endParaRPr lang="de-AT"/>
           </a:p>
@@ -1872,7 +1872,7 @@
     </p:spTree>
     <p:extLst>
       <p:ext uri="{BB962C8B-B14F-4D97-AF65-F5344CB8AC3E}">
-        <p14:creationId xmlns:p14="http://schemas.microsoft.com/office/powerpoint/2010/main" val="4044846174"/>
+        <p14:creationId xmlns:p14="http://schemas.microsoft.com/office/powerpoint/2010/main" val="2235274591"/>
       </p:ext>
     </p:extLst>
   </p:cSld>
@@ -1911,8 +1911,8 @@
         </p:nvSpPr>
         <p:spPr>
           <a:xfrm>
-            <a:off x="839789" y="287972"/>
-            <a:ext cx="3932237" cy="1007904"/>
+            <a:off x="828198" y="287972"/>
+            <a:ext cx="3877964" cy="1007904"/>
           </a:xfrm>
         </p:spPr>
         <p:txBody>
@@ -1943,8 +1943,8 @@
         </p:nvSpPr>
         <p:spPr>
           <a:xfrm>
-            <a:off x="5183188" y="621941"/>
-            <a:ext cx="6172200" cy="3069707"/>
+            <a:off x="5111649" y="621941"/>
+            <a:ext cx="6087011" cy="3069707"/>
           </a:xfrm>
         </p:spPr>
         <p:txBody>
@@ -2028,8 +2028,8 @@
         </p:nvSpPr>
         <p:spPr>
           <a:xfrm>
-            <a:off x="839789" y="1295877"/>
-            <a:ext cx="3932237" cy="2400771"/>
+            <a:off x="828198" y="1295877"/>
+            <a:ext cx="3877964" cy="2400771"/>
           </a:xfrm>
         </p:spPr>
         <p:txBody>
@@ -2098,7 +2098,7 @@
           <a:p>
             <a:fld id="{98DAC7ED-0124-4475-AB10-3A7CB843D580}" type="datetimeFigureOut">
               <a:rPr lang="de-AT" smtClean="0"/>
-              <a:t>06.03.2024</a:t>
+              <a:t>16.06.2026</a:t>
             </a:fld>
             <a:endParaRPr lang="de-AT"/>
           </a:p>
@@ -2149,7 +2149,7 @@
     </p:spTree>
     <p:extLst>
       <p:ext uri="{BB962C8B-B14F-4D97-AF65-F5344CB8AC3E}">
-        <p14:creationId xmlns:p14="http://schemas.microsoft.com/office/powerpoint/2010/main" val="460369536"/>
+        <p14:creationId xmlns:p14="http://schemas.microsoft.com/office/powerpoint/2010/main" val="2952379459"/>
       </p:ext>
     </p:extLst>
   </p:cSld>
@@ -2188,8 +2188,8 @@
         </p:nvSpPr>
         <p:spPr>
           <a:xfrm>
-            <a:off x="839789" y="287972"/>
-            <a:ext cx="3932237" cy="1007904"/>
+            <a:off x="828198" y="287972"/>
+            <a:ext cx="3877964" cy="1007904"/>
           </a:xfrm>
         </p:spPr>
         <p:txBody>
@@ -2220,8 +2220,8 @@
         </p:nvSpPr>
         <p:spPr>
           <a:xfrm>
-            <a:off x="5183188" y="621941"/>
-            <a:ext cx="6172200" cy="3069707"/>
+            <a:off x="5111649" y="621941"/>
+            <a:ext cx="6087011" cy="3069707"/>
           </a:xfrm>
         </p:spPr>
         <p:txBody>
@@ -2285,8 +2285,8 @@
         </p:nvSpPr>
         <p:spPr>
           <a:xfrm>
-            <a:off x="839789" y="1295877"/>
-            <a:ext cx="3932237" cy="2400771"/>
+            <a:off x="828198" y="1295877"/>
+            <a:ext cx="3877964" cy="2400771"/>
           </a:xfrm>
         </p:spPr>
         <p:txBody>
@@ -2355,7 +2355,7 @@
           <a:p>
             <a:fld id="{98DAC7ED-0124-4475-AB10-3A7CB843D580}" type="datetimeFigureOut">
               <a:rPr lang="de-AT" smtClean="0"/>
-              <a:t>06.03.2024</a:t>
+              <a:t>16.06.2026</a:t>
             </a:fld>
             <a:endParaRPr lang="de-AT"/>
           </a:p>
@@ -2406,7 +2406,7 @@
     </p:spTree>
     <p:extLst>
       <p:ext uri="{BB962C8B-B14F-4D97-AF65-F5344CB8AC3E}">
-        <p14:creationId xmlns:p14="http://schemas.microsoft.com/office/powerpoint/2010/main" val="3377098099"/>
+        <p14:creationId xmlns:p14="http://schemas.microsoft.com/office/powerpoint/2010/main" val="4193925969"/>
       </p:ext>
     </p:extLst>
   </p:cSld>
@@ -2450,8 +2450,8 @@
         </p:nvSpPr>
         <p:spPr>
           <a:xfrm>
-            <a:off x="838200" y="229978"/>
-            <a:ext cx="10515600" cy="834921"/>
+            <a:off x="826631" y="229978"/>
+            <a:ext cx="10370463" cy="834921"/>
           </a:xfrm>
           <a:prstGeom prst="rect">
             <a:avLst/>
@@ -2483,8 +2483,8 @@
         </p:nvSpPr>
         <p:spPr>
           <a:xfrm>
-            <a:off x="838200" y="1149890"/>
-            <a:ext cx="10515600" cy="2740739"/>
+            <a:off x="826631" y="1149890"/>
+            <a:ext cx="10370463" cy="2740739"/>
           </a:xfrm>
           <a:prstGeom prst="rect">
             <a:avLst/>
@@ -2545,8 +2545,8 @@
         </p:nvSpPr>
         <p:spPr>
           <a:xfrm>
-            <a:off x="838200" y="4003618"/>
-            <a:ext cx="2743200" cy="229978"/>
+            <a:off x="826631" y="4003618"/>
+            <a:ext cx="2705338" cy="229978"/>
           </a:xfrm>
           <a:prstGeom prst="rect">
             <a:avLst/>
@@ -2568,7 +2568,7 @@
           <a:p>
             <a:fld id="{98DAC7ED-0124-4475-AB10-3A7CB843D580}" type="datetimeFigureOut">
               <a:rPr lang="de-AT" smtClean="0"/>
-              <a:t>06.03.2024</a:t>
+              <a:t>16.06.2026</a:t>
             </a:fld>
             <a:endParaRPr lang="de-AT"/>
           </a:p>
@@ -2586,8 +2586,8 @@
         </p:nvSpPr>
         <p:spPr>
           <a:xfrm>
-            <a:off x="4038600" y="4003618"/>
-            <a:ext cx="4114800" cy="229978"/>
+            <a:off x="3982859" y="4003618"/>
+            <a:ext cx="4058007" cy="229978"/>
           </a:xfrm>
           <a:prstGeom prst="rect">
             <a:avLst/>
@@ -2623,8 +2623,8 @@
         </p:nvSpPr>
         <p:spPr>
           <a:xfrm>
-            <a:off x="8610600" y="4003618"/>
-            <a:ext cx="2743200" cy="229978"/>
+            <a:off x="8491756" y="4003618"/>
+            <a:ext cx="2705338" cy="229978"/>
           </a:xfrm>
           <a:prstGeom prst="rect">
             <a:avLst/>
@@ -2655,23 +2655,23 @@
     </p:spTree>
     <p:extLst>
       <p:ext uri="{BB962C8B-B14F-4D97-AF65-F5344CB8AC3E}">
-        <p14:creationId xmlns:p14="http://schemas.microsoft.com/office/powerpoint/2010/main" val="1959852607"/>
+        <p14:creationId xmlns:p14="http://schemas.microsoft.com/office/powerpoint/2010/main" val="1973191776"/>
       </p:ext>
     </p:extLst>
   </p:cSld>
   <p:clrMap bg1="lt1" tx1="dk1" bg2="lt2" tx2="dk2" accent1="accent1" accent2="accent2" accent3="accent3" accent4="accent4" accent5="accent5" accent6="accent6" hlink="hlink" folHlink="folHlink"/>
   <p:sldLayoutIdLst>
-    <p:sldLayoutId id="2147483673" r:id="rId1"/>
-    <p:sldLayoutId id="2147483674" r:id="rId2"/>
-    <p:sldLayoutId id="2147483675" r:id="rId3"/>
-    <p:sldLayoutId id="2147483676" r:id="rId4"/>
-    <p:sldLayoutId id="2147483677" r:id="rId5"/>
-    <p:sldLayoutId id="2147483678" r:id="rId6"/>
-    <p:sldLayoutId id="2147483679" r:id="rId7"/>
-    <p:sldLayoutId id="2147483680" r:id="rId8"/>
-    <p:sldLayoutId id="2147483681" r:id="rId9"/>
-    <p:sldLayoutId id="2147483682" r:id="rId10"/>
-    <p:sldLayoutId id="2147483683" r:id="rId11"/>
+    <p:sldLayoutId id="2147483685" r:id="rId1"/>
+    <p:sldLayoutId id="2147483686" r:id="rId2"/>
+    <p:sldLayoutId id="2147483687" r:id="rId3"/>
+    <p:sldLayoutId id="2147483688" r:id="rId4"/>
+    <p:sldLayoutId id="2147483689" r:id="rId5"/>
+    <p:sldLayoutId id="2147483690" r:id="rId6"/>
+    <p:sldLayoutId id="2147483691" r:id="rId7"/>
+    <p:sldLayoutId id="2147483692" r:id="rId8"/>
+    <p:sldLayoutId id="2147483693" r:id="rId9"/>
+    <p:sldLayoutId id="2147483694" r:id="rId10"/>
+    <p:sldLayoutId id="2147483695" r:id="rId11"/>
   </p:sldLayoutIdLst>
   <p:txStyles>
     <p:titleStyle>
@@ -2973,9 +2973,61 @@
           <a:chExt cx="0" cy="0"/>
         </a:xfrm>
       </p:grpSpPr>
+      <p:sp>
+        <p:nvSpPr>
+          <p:cNvPr id="4" name="Rectangle 3">
+            <a:extLst>
+              <a:ext uri="{FF2B5EF4-FFF2-40B4-BE49-F238E27FC236}">
+                <a16:creationId xmlns:a16="http://schemas.microsoft.com/office/drawing/2014/main" id="{E707CBB2-CAB2-BEA0-C43C-1D5F4FF1CF89}"/>
+              </a:ext>
+            </a:extLst>
+          </p:cNvPr>
+          <p:cNvSpPr/>
+          <p:nvPr/>
+        </p:nvSpPr>
+        <p:spPr>
+          <a:xfrm>
+            <a:off x="0" y="0"/>
+            <a:ext cx="12015765" cy="4319588"/>
+          </a:xfrm>
+          <a:prstGeom prst="rect">
+            <a:avLst/>
+          </a:prstGeom>
+          <a:solidFill>
+            <a:schemeClr val="bg1"/>
+          </a:solidFill>
+          <a:ln>
+            <a:noFill/>
+          </a:ln>
+        </p:spPr>
+        <p:style>
+          <a:lnRef idx="2">
+            <a:schemeClr val="accent1">
+              <a:shade val="15000"/>
+            </a:schemeClr>
+          </a:lnRef>
+          <a:fillRef idx="1">
+            <a:schemeClr val="accent1"/>
+          </a:fillRef>
+          <a:effectRef idx="0">
+            <a:schemeClr val="accent1"/>
+          </a:effectRef>
+          <a:fontRef idx="minor">
+            <a:schemeClr val="lt1"/>
+          </a:fontRef>
+        </p:style>
+        <p:txBody>
+          <a:bodyPr rtlCol="0" anchor="ctr"/>
+          <a:lstStyle/>
+          <a:p>
+            <a:pPr algn="ctr"/>
+            <a:endParaRPr lang="de-AT" dirty="0"/>
+          </a:p>
+        </p:txBody>
+      </p:sp>
       <p:grpSp>
         <p:nvGrpSpPr>
-          <p:cNvPr id="2" name="Group 1">
+          <p:cNvPr id="5" name="Group 4">
             <a:extLst>
               <a:ext uri="{FF2B5EF4-FFF2-40B4-BE49-F238E27FC236}">
                 <a16:creationId xmlns:a16="http://schemas.microsoft.com/office/drawing/2014/main" id="{9ADD9CC6-1F67-47D0-B939-9176047B44FB}"/>
@@ -2987,7 +3039,7 @@
         </p:nvGrpSpPr>
         <p:grpSpPr>
           <a:xfrm>
-            <a:off x="213056" y="227732"/>
+            <a:off x="176235" y="147458"/>
             <a:ext cx="11688886" cy="4024672"/>
             <a:chOff x="213056" y="227732"/>
             <a:chExt cx="11688886" cy="4024672"/>
@@ -2995,7 +3047,7 @@
         </p:grpSpPr>
         <p:sp>
           <p:nvSpPr>
-            <p:cNvPr id="85" name="TextBox 84">
+            <p:cNvPr id="6" name="TextBox 5">
               <a:extLst>
                 <a:ext uri="{FF2B5EF4-FFF2-40B4-BE49-F238E27FC236}">
                   <a16:creationId xmlns:a16="http://schemas.microsoft.com/office/drawing/2014/main" id="{A08EE27B-0ED6-4BFE-8C6E-0B807E71486C}"/>
@@ -3039,7 +3091,7 @@
         </p:sp>
         <p:sp>
           <p:nvSpPr>
-            <p:cNvPr id="86" name="TextBox 85">
+            <p:cNvPr id="7" name="TextBox 6">
               <a:extLst>
                 <a:ext uri="{FF2B5EF4-FFF2-40B4-BE49-F238E27FC236}">
                   <a16:creationId xmlns:a16="http://schemas.microsoft.com/office/drawing/2014/main" id="{ABA3453E-A4C6-4F56-9212-606CBA299D0A}"/>
@@ -3082,7 +3134,7 @@
         </p:sp>
         <p:sp>
           <p:nvSpPr>
-            <p:cNvPr id="87" name="TextBox 86">
+            <p:cNvPr id="8" name="TextBox 7">
               <a:extLst>
                 <a:ext uri="{FF2B5EF4-FFF2-40B4-BE49-F238E27FC236}">
                   <a16:creationId xmlns:a16="http://schemas.microsoft.com/office/drawing/2014/main" id="{72335272-C8F1-43BC-AD04-306BA0FFE9CF}"/>
@@ -3125,7 +3177,7 @@
         </p:sp>
         <p:sp>
           <p:nvSpPr>
-            <p:cNvPr id="88" name="TextBox 87">
+            <p:cNvPr id="9" name="TextBox 8">
               <a:extLst>
                 <a:ext uri="{FF2B5EF4-FFF2-40B4-BE49-F238E27FC236}">
                   <a16:creationId xmlns:a16="http://schemas.microsoft.com/office/drawing/2014/main" id="{02A548F8-4E1F-4A4C-82EA-045C2335CCD9}"/>
@@ -3168,7 +3220,7 @@
         </p:sp>
         <p:sp>
           <p:nvSpPr>
-            <p:cNvPr id="89" name="TextBox 88">
+            <p:cNvPr id="10" name="TextBox 9">
               <a:extLst>
                 <a:ext uri="{FF2B5EF4-FFF2-40B4-BE49-F238E27FC236}">
                   <a16:creationId xmlns:a16="http://schemas.microsoft.com/office/drawing/2014/main" id="{08788219-EB4D-409E-B07C-5730BB942A1F}"/>
@@ -3215,7 +3267,7 @@
         </p:sp>
         <p:sp>
           <p:nvSpPr>
-            <p:cNvPr id="90" name="TextBox 89">
+            <p:cNvPr id="11" name="TextBox 10">
               <a:extLst>
                 <a:ext uri="{FF2B5EF4-FFF2-40B4-BE49-F238E27FC236}">
                   <a16:creationId xmlns:a16="http://schemas.microsoft.com/office/drawing/2014/main" id="{34919C27-DFA0-4D8A-A601-A59528F5E4B6}"/>
@@ -3262,7 +3314,7 @@
         </p:sp>
         <p:cxnSp>
           <p:nvCxnSpPr>
-            <p:cNvPr id="91" name="Straight Arrow Connector 90">
+            <p:cNvPr id="12" name="Straight Arrow Connector 11">
               <a:extLst>
                 <a:ext uri="{FF2B5EF4-FFF2-40B4-BE49-F238E27FC236}">
                   <a16:creationId xmlns:a16="http://schemas.microsoft.com/office/drawing/2014/main" id="{463C70AE-6F58-4FAC-9346-8DC6FEF4A6FB}"/>
@@ -3304,7 +3356,7 @@
         </p:cxnSp>
         <p:cxnSp>
           <p:nvCxnSpPr>
-            <p:cNvPr id="92" name="Straight Arrow Connector 91">
+            <p:cNvPr id="13" name="Straight Arrow Connector 12">
               <a:extLst>
                 <a:ext uri="{FF2B5EF4-FFF2-40B4-BE49-F238E27FC236}">
                   <a16:creationId xmlns:a16="http://schemas.microsoft.com/office/drawing/2014/main" id="{F6115A48-4EA1-4DF8-B139-75B85F693C80}"/>
@@ -3346,7 +3398,7 @@
         </p:cxnSp>
         <p:cxnSp>
           <p:nvCxnSpPr>
-            <p:cNvPr id="93" name="Straight Arrow Connector 92">
+            <p:cNvPr id="14" name="Straight Arrow Connector 13">
               <a:extLst>
                 <a:ext uri="{FF2B5EF4-FFF2-40B4-BE49-F238E27FC236}">
                   <a16:creationId xmlns:a16="http://schemas.microsoft.com/office/drawing/2014/main" id="{43FD8E7F-E514-434F-B51F-FC92BFEF34ED}"/>
@@ -3390,7 +3442,7 @@
         </p:cxnSp>
         <p:cxnSp>
           <p:nvCxnSpPr>
-            <p:cNvPr id="94" name="Straight Arrow Connector 93">
+            <p:cNvPr id="15" name="Straight Arrow Connector 14">
               <a:extLst>
                 <a:ext uri="{FF2B5EF4-FFF2-40B4-BE49-F238E27FC236}">
                   <a16:creationId xmlns:a16="http://schemas.microsoft.com/office/drawing/2014/main" id="{417F4992-2F28-4F19-9DFE-4279FB08EAE1}"/>
@@ -3434,7 +3486,7 @@
         </p:cxnSp>
         <p:cxnSp>
           <p:nvCxnSpPr>
-            <p:cNvPr id="95" name="Straight Arrow Connector 94">
+            <p:cNvPr id="16" name="Straight Arrow Connector 15">
               <a:extLst>
                 <a:ext uri="{FF2B5EF4-FFF2-40B4-BE49-F238E27FC236}">
                   <a16:creationId xmlns:a16="http://schemas.microsoft.com/office/drawing/2014/main" id="{D0349D8A-15B6-496F-9BE8-382A94F217C2}"/>
@@ -3478,7 +3530,7 @@
         </p:cxnSp>
         <p:cxnSp>
           <p:nvCxnSpPr>
-            <p:cNvPr id="96" name="Straight Arrow Connector 95">
+            <p:cNvPr id="17" name="Straight Arrow Connector 16">
               <a:extLst>
                 <a:ext uri="{FF2B5EF4-FFF2-40B4-BE49-F238E27FC236}">
                   <a16:creationId xmlns:a16="http://schemas.microsoft.com/office/drawing/2014/main" id="{034997D4-BB4F-42A6-9E9F-509C5337AEBE}"/>
@@ -3522,7 +3574,7 @@
         </p:cxnSp>
         <p:cxnSp>
           <p:nvCxnSpPr>
-            <p:cNvPr id="97" name="Straight Arrow Connector 96">
+            <p:cNvPr id="18" name="Straight Arrow Connector 17">
               <a:extLst>
                 <a:ext uri="{FF2B5EF4-FFF2-40B4-BE49-F238E27FC236}">
                   <a16:creationId xmlns:a16="http://schemas.microsoft.com/office/drawing/2014/main" id="{58C725FC-ADA8-4CDF-8FA4-6D2FEDB1EFC9}"/>
@@ -3566,7 +3618,7 @@
         </p:cxnSp>
         <p:cxnSp>
           <p:nvCxnSpPr>
-            <p:cNvPr id="98" name="Straight Arrow Connector 97">
+            <p:cNvPr id="19" name="Straight Arrow Connector 18">
               <a:extLst>
                 <a:ext uri="{FF2B5EF4-FFF2-40B4-BE49-F238E27FC236}">
                   <a16:creationId xmlns:a16="http://schemas.microsoft.com/office/drawing/2014/main" id="{21F2869C-A86B-4921-B99D-7A10BB562A7A}"/>
@@ -3610,7 +3662,7 @@
         </p:cxnSp>
         <p:sp>
           <p:nvSpPr>
-            <p:cNvPr id="99" name="TextBox 98">
+            <p:cNvPr id="20" name="TextBox 19">
               <a:extLst>
                 <a:ext uri="{FF2B5EF4-FFF2-40B4-BE49-F238E27FC236}">
                   <a16:creationId xmlns:a16="http://schemas.microsoft.com/office/drawing/2014/main" id="{438D4C43-382A-4E70-BD37-6AADB465C5E5}"/>
@@ -3646,7 +3698,7 @@
         </p:sp>
         <p:sp>
           <p:nvSpPr>
-            <p:cNvPr id="100" name="TextBox 99">
+            <p:cNvPr id="21" name="TextBox 20">
               <a:extLst>
                 <a:ext uri="{FF2B5EF4-FFF2-40B4-BE49-F238E27FC236}">
                   <a16:creationId xmlns:a16="http://schemas.microsoft.com/office/drawing/2014/main" id="{F9B2C732-0831-45B6-B0F3-F20C137C84DE}"/>
@@ -3682,7 +3734,7 @@
         </p:sp>
         <p:sp>
           <p:nvSpPr>
-            <p:cNvPr id="101" name="TextBox 100">
+            <p:cNvPr id="22" name="TextBox 21">
               <a:extLst>
                 <a:ext uri="{FF2B5EF4-FFF2-40B4-BE49-F238E27FC236}">
                   <a16:creationId xmlns:a16="http://schemas.microsoft.com/office/drawing/2014/main" id="{5C392BD6-51DF-43FE-8456-92B9FF8239AC}"/>
@@ -3718,7 +3770,7 @@
         </p:sp>
         <p:sp>
           <p:nvSpPr>
-            <p:cNvPr id="102" name="TextBox 101">
+            <p:cNvPr id="23" name="TextBox 22">
               <a:extLst>
                 <a:ext uri="{FF2B5EF4-FFF2-40B4-BE49-F238E27FC236}">
                   <a16:creationId xmlns:a16="http://schemas.microsoft.com/office/drawing/2014/main" id="{95B093E8-AB5C-4E50-B6DE-5199A762C8A4}"/>
@@ -3803,7 +3855,7 @@
         </p:sp>
         <p:sp>
           <p:nvSpPr>
-            <p:cNvPr id="103" name="TextBox 102">
+            <p:cNvPr id="24" name="TextBox 23">
               <a:extLst>
                 <a:ext uri="{FF2B5EF4-FFF2-40B4-BE49-F238E27FC236}">
                   <a16:creationId xmlns:a16="http://schemas.microsoft.com/office/drawing/2014/main" id="{1236D719-568D-4A43-977B-8166647556F8}"/>
@@ -3839,7 +3891,7 @@
         </p:sp>
         <p:sp>
           <p:nvSpPr>
-            <p:cNvPr id="104" name="TextBox 103">
+            <p:cNvPr id="25" name="TextBox 24">
               <a:extLst>
                 <a:ext uri="{FF2B5EF4-FFF2-40B4-BE49-F238E27FC236}">
                   <a16:creationId xmlns:a16="http://schemas.microsoft.com/office/drawing/2014/main" id="{1C69EE09-6994-4743-9755-6FD34A51A151}"/>
@@ -3875,7 +3927,7 @@
         </p:sp>
         <p:sp>
           <p:nvSpPr>
-            <p:cNvPr id="105" name="TextBox 104">
+            <p:cNvPr id="26" name="TextBox 25">
               <a:extLst>
                 <a:ext uri="{FF2B5EF4-FFF2-40B4-BE49-F238E27FC236}">
                   <a16:creationId xmlns:a16="http://schemas.microsoft.com/office/drawing/2014/main" id="{0AAD993C-AD65-4CD8-A561-0F499478A568}"/>
@@ -3924,7 +3976,7 @@
         </p:sp>
         <p:sp>
           <p:nvSpPr>
-            <p:cNvPr id="106" name="TextBox 105">
+            <p:cNvPr id="27" name="TextBox 26">
               <a:extLst>
                 <a:ext uri="{FF2B5EF4-FFF2-40B4-BE49-F238E27FC236}">
                   <a16:creationId xmlns:a16="http://schemas.microsoft.com/office/drawing/2014/main" id="{D736A967-40DC-4011-BF8B-52256685C19C}"/>
@@ -3973,7 +4025,7 @@
         </p:sp>
         <p:sp>
           <p:nvSpPr>
-            <p:cNvPr id="107" name="TextBox 106">
+            <p:cNvPr id="28" name="TextBox 27">
               <a:extLst>
                 <a:ext uri="{FF2B5EF4-FFF2-40B4-BE49-F238E27FC236}">
                   <a16:creationId xmlns:a16="http://schemas.microsoft.com/office/drawing/2014/main" id="{A22C1ABA-748A-4F57-9BE5-A826408343E1}"/>
@@ -4020,7 +4072,7 @@
         </p:sp>
         <p:sp>
           <p:nvSpPr>
-            <p:cNvPr id="108" name="TextBox 107">
+            <p:cNvPr id="29" name="TextBox 28">
               <a:extLst>
                 <a:ext uri="{FF2B5EF4-FFF2-40B4-BE49-F238E27FC236}">
                   <a16:creationId xmlns:a16="http://schemas.microsoft.com/office/drawing/2014/main" id="{FC25D197-D620-4FB6-9E52-9E2F8096DE7E}"/>
@@ -4069,7 +4121,7 @@
         </p:sp>
         <p:sp>
           <p:nvSpPr>
-            <p:cNvPr id="109" name="TextBox 108">
+            <p:cNvPr id="30" name="TextBox 29">
               <a:extLst>
                 <a:ext uri="{FF2B5EF4-FFF2-40B4-BE49-F238E27FC236}">
                   <a16:creationId xmlns:a16="http://schemas.microsoft.com/office/drawing/2014/main" id="{1DB52A4F-345D-4F69-AD7A-6178390C7D85}"/>
@@ -4118,7 +4170,7 @@
         </p:sp>
         <p:sp>
           <p:nvSpPr>
-            <p:cNvPr id="110" name="TextBox 109">
+            <p:cNvPr id="34" name="TextBox 33">
               <a:extLst>
                 <a:ext uri="{FF2B5EF4-FFF2-40B4-BE49-F238E27FC236}">
                   <a16:creationId xmlns:a16="http://schemas.microsoft.com/office/drawing/2014/main" id="{B0325DE6-B480-4280-978D-5A3568F7F823}"/>
@@ -4165,7 +4217,7 @@
         </p:sp>
         <p:sp>
           <p:nvSpPr>
-            <p:cNvPr id="111" name="TextBox 110">
+            <p:cNvPr id="35" name="TextBox 34">
               <a:extLst>
                 <a:ext uri="{FF2B5EF4-FFF2-40B4-BE49-F238E27FC236}">
                   <a16:creationId xmlns:a16="http://schemas.microsoft.com/office/drawing/2014/main" id="{86F76335-CDF4-4364-9006-2A8258C548E7}"/>
@@ -4214,7 +4266,7 @@
         </p:sp>
         <p:sp>
           <p:nvSpPr>
-            <p:cNvPr id="112" name="TextBox 111">
+            <p:cNvPr id="36" name="TextBox 35">
               <a:extLst>
                 <a:ext uri="{FF2B5EF4-FFF2-40B4-BE49-F238E27FC236}">
                   <a16:creationId xmlns:a16="http://schemas.microsoft.com/office/drawing/2014/main" id="{7E08DA84-26F3-4560-9326-18989FD222EC}"/>
@@ -4261,7 +4313,7 @@
         </p:sp>
         <p:sp>
           <p:nvSpPr>
-            <p:cNvPr id="113" name="TextBox 112">
+            <p:cNvPr id="37" name="TextBox 36">
               <a:extLst>
                 <a:ext uri="{FF2B5EF4-FFF2-40B4-BE49-F238E27FC236}">
                   <a16:creationId xmlns:a16="http://schemas.microsoft.com/office/drawing/2014/main" id="{20179043-4531-4318-ADDA-3275527A9200}"/>
@@ -4304,7 +4356,7 @@
         </p:sp>
         <p:sp>
           <p:nvSpPr>
-            <p:cNvPr id="31" name="TextBox 30">
+            <p:cNvPr id="38" name="TextBox 37">
               <a:extLst>
                 <a:ext uri="{FF2B5EF4-FFF2-40B4-BE49-F238E27FC236}">
                   <a16:creationId xmlns:a16="http://schemas.microsoft.com/office/drawing/2014/main" id="{60CAF32B-8BD7-45E8-8127-09B40ABC60CA}"/>
@@ -4353,7 +4405,7 @@
         </p:sp>
         <p:sp>
           <p:nvSpPr>
-            <p:cNvPr id="32" name="TextBox 31">
+            <p:cNvPr id="39" name="TextBox 38">
               <a:extLst>
                 <a:ext uri="{FF2B5EF4-FFF2-40B4-BE49-F238E27FC236}">
                   <a16:creationId xmlns:a16="http://schemas.microsoft.com/office/drawing/2014/main" id="{0BD78ECC-1524-4689-902C-9380403FDD7F}"/>
@@ -4400,7 +4452,7 @@
         </p:sp>
         <p:sp>
           <p:nvSpPr>
-            <p:cNvPr id="33" name="TextBox 32">
+            <p:cNvPr id="40" name="TextBox 39">
               <a:extLst>
                 <a:ext uri="{FF2B5EF4-FFF2-40B4-BE49-F238E27FC236}">
                   <a16:creationId xmlns:a16="http://schemas.microsoft.com/office/drawing/2014/main" id="{679A5EEE-A68B-4097-B3F0-AA733B581BAB}"/>
@@ -4462,9 +4514,9 @@
 </file>
 
 <file path=ppt/theme/theme1.xml><?xml version="1.0" encoding="utf-8"?>
-<a:theme xmlns:a="http://schemas.openxmlformats.org/drawingml/2006/main" name="Office Theme">
+<a:theme xmlns:a="http://schemas.openxmlformats.org/drawingml/2006/main" name="Office 2013 - 2022 Theme">
   <a:themeElements>
-    <a:clrScheme name="Office Theme">
+    <a:clrScheme name="Office 2013 - 2022 Theme">
       <a:dk1>
         <a:sysClr val="windowText" lastClr="000000"/>
       </a:dk1>
@@ -4502,7 +4554,7 @@
         <a:srgbClr val="954F72"/>
       </a:folHlink>
     </a:clrScheme>
-    <a:fontScheme name="Office Theme">
+    <a:fontScheme name="Office 2013 - 2022 Theme">
       <a:majorFont>
         <a:latin typeface="Calibri Light" panose="020F0302020204030204"/>
         <a:ea typeface=""/>
@@ -4574,7 +4626,7 @@
         <a:font script="Geor" typeface="Sylfaen"/>
       </a:minorFont>
     </a:fontScheme>
-    <a:fmtScheme name="Office Theme">
+    <a:fmtScheme name="Office 2013 - 2022 Theme">
       <a:fillStyleLst>
         <a:solidFill>
           <a:schemeClr val="phClr"/>
@@ -4716,7 +4768,7 @@
   <a:extraClrSchemeLst/>
   <a:extLst>
     <a:ext uri="{05A4C25C-085E-4340-85A3-A5531E510DB2}">
-      <thm15:themeFamily xmlns:thm15="http://schemas.microsoft.com/office/thememl/2012/main" name="Office Theme" id="{62F939B6-93AF-4DB8-9C6B-D6C7DFDC589F}" vid="{4A3C46E8-61CC-4603-A589-7422A47A8E4A}"/>
+      <thm15:themeFamily xmlns:thm15="http://schemas.microsoft.com/office/thememl/2012/main" name="Office 2013 - 2022 Theme" id="{62F939B6-93AF-4DB8-9C6B-D6C7DFDC589F}" vid="{4A3C46E8-61CC-4603-A589-7422A47A8E4A}"/>
     </a:ext>
   </a:extLst>
 </a:theme>

</xml_diff>